<commit_message>
Exam Corner topics image + PowerPoint: add Structural Organisation in Animals
Topics image: new Ch 7 card (frog habitat & morphology, hibernation &
aestivation, digestive system); Study first now reads "Animal Kingdom & Frog";
Practise drawing is Plant cell, Mitochondrion, Frog digestive system, Cell cycle.
PowerPoint now matches the in-app presentation: chart with Structural Org. in
Animals, 61 focus marks, Animal Kingdom & Structural Organisation slide
(Chapters 4 & 7, 20 marks), four diagrams, updated 7-day plan and narration.

Co-Authored-By: Claude Opus 5.5 <noreply@anthropic.com>
Claude-Session: https://claude.ai/code/session_014QeQ9is1mz9E1otG3meiyh
</commit_message>
<xml_diff>
--- a/exam-corner/pu1-midterm-2026-topics-and-tips.pptx
+++ b/exam-corner/pu1-midterm-2026-topics-and-tips.pptx
@@ -123,14 +123,14 @@
   <p:extLst>
     <p:ext uri="{521415D9-36F7-43E2-AB2F-B90AF26B5E84}">
       <p14:sectionLst xmlns:p14="http://schemas.microsoft.com/office/powerpoint/2010/main">
-        <p14:section name="Overview" id="{187ec808-1d87-dcb9-2276-24dae04c77f7}">
+        <p14:section name="Overview" id="{229fbdab-c3a8-da75-9edd-5912b9098b99}">
           <p14:sldIdLst>
             <p14:sldId id="256"/>
             <p14:sldId id="257"/>
             <p14:sldId id="258"/>
           </p14:sldIdLst>
         </p14:section>
-        <p14:section name="Topics to practise" id="{89f79021-9de9-ded7-5a61-abdcae740b71}">
+        <p14:section name="Topics to practise" id="{159292c8-c8cc-361e-ed38-dfc981ab04b7}">
           <p14:sldIdLst>
             <p14:sldId id="259"/>
             <p14:sldId id="260"/>
@@ -141,7 +141,7 @@
             <p14:sldId id="265"/>
           </p14:sldIdLst>
         </p14:section>
-        <p14:section name="Tips to score high" id="{8a1a9b0a-b3fa-1779-6ee8-f1278f553e81}">
+        <p14:section name="Tips to score high" id="{3995aca3-89af-97cd-3033-4073f7bd47b7}">
           <p14:sldIdLst>
             <p14:sldId id="266"/>
             <p14:sldId id="267"/>
@@ -151,7 +151,7 @@
             <p14:sldId id="271"/>
           </p14:sldIdLst>
         </p14:section>
-        <p14:section name="Close" id="{d4ae81b6-d891-d214-91f9-c512cfb520b5}">
+        <p14:section name="Close" id="{69359046-0191-dd2e-b055-9d06a98b640a}">
           <p14:sldIdLst>
             <p14:sldId id="272"/>
           </p14:sldIdLst>
@@ -253,35 +253,38 @@
           </c:dLbls>
           <c:cat>
             <c:multiLvlStrRef>
-              <c:f>Sheet1!$A$2:$A$10</c:f>
+              <c:f>Sheet1!$A$2:$A$11</c:f>
               <c:multiLvlStrCache>
-                <c:ptCount val="9"/>
+                <c:ptCount val="10"/>
                 <c:lvl>
                   <c:pt idx="0">
+                    <c:v>Structural Org. in Animals</c:v>
+                  </c:pt>
+                  <c:pt idx="1">
                     <c:v>The Living World</c:v>
                   </c:pt>
-                  <c:pt idx="1">
+                  <c:pt idx="2">
                     <c:v>Anatomy</c:v>
                   </c:pt>
-                  <c:pt idx="2">
+                  <c:pt idx="3">
                     <c:v>Plant Kingdom</c:v>
                   </c:pt>
-                  <c:pt idx="3">
+                  <c:pt idx="4">
                     <c:v>Biological Classification</c:v>
                   </c:pt>
-                  <c:pt idx="4">
+                  <c:pt idx="5">
                     <c:v>Morphology</c:v>
                   </c:pt>
-                  <c:pt idx="5">
+                  <c:pt idx="6">
                     <c:v>Cell Cycle</c:v>
                   </c:pt>
-                  <c:pt idx="6">
+                  <c:pt idx="7">
                     <c:v>Biomolecules</c:v>
                   </c:pt>
-                  <c:pt idx="7">
+                  <c:pt idx="8">
                     <c:v>Animal Kingdom</c:v>
                   </c:pt>
-                  <c:pt idx="8">
+                  <c:pt idx="9">
                     <c:v>Cell: Unit of Life</c:v>
                   </c:pt>
                 </c:lvl>
@@ -290,36 +293,39 @@
           </c:cat>
           <c:val>
             <c:numRef>
-              <c:f>Sheet1!$B$2:$B$10</c:f>
+              <c:f>Sheet1!$B$2:$B$11</c:f>
               <c:numCache>
                 <c:formatCode>General</c:formatCode>
-                <c:ptCount val="9"/>
+                <c:ptCount val="10"/>
                 <c:pt idx="0">
                   <c:v>4</c:v>
                 </c:pt>
                 <c:pt idx="1">
-                  <c:v>5</c:v>
+                  <c:v>4</c:v>
                 </c:pt>
                 <c:pt idx="2">
-                  <c:v>10</c:v>
+                  <c:v>5</c:v>
                 </c:pt>
                 <c:pt idx="3">
                   <c:v>10</c:v>
                 </c:pt>
                 <c:pt idx="4">
-                  <c:v>11</c:v>
+                  <c:v>10</c:v>
                 </c:pt>
                 <c:pt idx="5">
-                  <c:v>12</c:v>
+                  <c:v>11</c:v>
                 </c:pt>
                 <c:pt idx="6">
                   <c:v>12</c:v>
                 </c:pt>
                 <c:pt idx="7">
+                  <c:v>12</c:v>
+                </c:pt>
+                <c:pt idx="8">
                   <c:v>16</c:v>
                 </c:pt>
-                <c:pt idx="8">
-                  <c:v>25</c:v>
+                <c:pt idx="9">
+                  <c:v>21</c:v>
                 </c:pt>
               </c:numCache>
             </c:numRef>
@@ -855,7 +861,7 @@
             <a:r>
               <a:rPr lang="en-US" dirty="0"/>
               <a:t>ENGLISH
-Hello students. I'm Narendra Sir. In this session we will look at the important topics from the I PUC Biology mid-term paper, chapter by chapter, and I will share simple tips that help you score high marks. Keep a notebook ready and mark the topics you still need to revise.
+Hello students. I'm Narendra Sir. In this session we will look at the important topics from the first year P U C Biology mid-term paper, chapter by chapter, and I will share simple tips that help you score high marks. Keep a notebook ready and mark the topics you still need to revise.
 ಕನ್ನಡ (KANNADA)
 ನಮಸ್ಕಾರ ವಿದ್ಯಾರ್ಥಿಗಳೇ. ನಾನು ನರೇಂದ್ರ ಸರ್. ಈ ಅವಧಿಯಲ್ಲಿ ಪ್ರಥಮ ಪಿಯುಸಿ ಜೀವಶಾಸ್ತ್ರ ಮಧ್ಯಾವಧಿ ಪ್ರಶ್ನೆಪತ್ರಿಕೆಯ ಪ್ರಮುಖ ವಿಷಯಗಳನ್ನು ಅಧ್ಯಾಯವಾರು ನೋಡೋಣ. ಹೆಚ್ಚು ಅಂಕ ಗಳಿಸಲು ಸಹಾಯ ಮಾಡುವ ಸರಳ ಸಲಹೆಗಳನ್ನೂ ನೀಡುತ್ತೇನೆ. ಒಂದು ನೋಟ್‌ಬುಕ್ ಇಟ್ಟುಕೊಂಡು, ಇನ್ನೂ ಪುನರಾವರ್ತಿಸಬೇಕಾದ ವಿಷಯಗಳನ್ನು ಗುರುತು ಮಾಡಿಕೊಳ್ಳಿ.
 हिंदी (HINDI)
@@ -1041,11 +1047,11 @@
             <a:r>
               <a:rPr lang="en-US" dirty="0"/>
               <a:t>ENGLISH
-Diagrams carry marks, and unlabelled diagrams get no marks. Practise these five until you can draw each one in about three minutes: the plant cell, the mitochondrion, the fluid mosaic model, the cell cycle, and the types of placentation. Draw with a pencil, keep the diagram large and neat, draw label lines straight and parallel, and write the title below the diagram.
+Diagrams carry marks, and unlabelled diagrams get no marks. Practise these four until you can draw each one in about three minutes: the plant cell, the mitochondrion, the digestive system of the frog, and the cell cycle. Draw with a pencil, keep the diagram large and neat, draw label lines straight and parallel, and write the title below the diagram.
 ಕನ್ನಡ (KANNADA)
-ಚಿತ್ರಗಳಿಗೆ ಅಂಕಗಳಿವೆ, ಹೆಸರಿಸದ ಚಿತ್ರಗಳಿಗೆ ಅಂಕವಿಲ್ಲ. ಈ ಐದು ಚಿತ್ರಗಳನ್ನು ತಲಾ ಸುಮಾರು ಮೂರು ನಿಮಿಷದಲ್ಲಿ ಬರೆಯುವಷ್ಟು ಅಭ್ಯಾಸ ಮಾಡಿ: ಸಸ್ಯಕೋಶ, ಮೈಟೊಕಾಂಡ್ರಿಯಾ, ದ್ರವ ಮೊಸಾಯಿಕ್ ಮಾದರಿ, ಜೀವಕೋಶ ಚಕ್ರ ಮತ್ತು ಬೀಜಾಂಡ ವಿನ್ಯಾಸದ ವಿಧಗಳು. ಪೆನ್ಸಿಲ್‌ನಿಂದ ಬರೆಯಿರಿ, ಚಿತ್ರ ದೊಡ್ಡದಾಗಿ ಮತ್ತು ಅಚ್ಚುಕಟ್ಟಾಗಿರಲಿ, ಹೆಸರಿಸುವ ಗೆರೆಗಳು ನೇರ ಮತ್ತು ಸಮಾಂತರವಾಗಿರಲಿ, ಮತ್ತು ಶೀರ್ಷಿಕೆಯನ್ನು ಚಿತ್ರದ ಕೆಳಗೆ ಬರೆಯಿರಿ.
+ಚಿತ್ರಗಳಿಗೆ ಅಂಕಗಳಿವೆ, ಹೆಸರಿಸದ ಚಿತ್ರಗಳಿಗೆ ಅಂಕವಿಲ್ಲ. ಈ ನಾಲ್ಕು ಚಿತ್ರಗಳನ್ನು ತಲಾ ಸುಮಾರು ಮೂರು ನಿಮಿಷದಲ್ಲಿ ಬರೆಯುವಷ್ಟು ಅಭ್ಯಾಸ ಮಾಡಿ: ಸಸ್ಯಕೋಶ, ಮೈಟೊಕಾಂಡ್ರಿಯಾ, ಕಪ್ಪೆಯ ಜೀರ್ಣಾಂಗ ವ್ಯವಸ್ಥೆ ಮತ್ತು ಜೀವಕೋಶ ಚಕ್ರ. ಪೆನ್ಸಿಲ್‌ನಿಂದ ಬರೆಯಿರಿ, ಚಿತ್ರ ದೊಡ್ಡದಾಗಿ ಮತ್ತು ಅಚ್ಚುಕಟ್ಟಾಗಿರಲಿ, ಹೆಸರಿಸುವ ಗೆರೆಗಳು ನೇರ ಮತ್ತು ಸಮಾಂತರವಾಗಿರಲಿ, ಮತ್ತು ಶೀರ್ಷಿಕೆಯನ್ನು ಚಿತ್ರದ ಕೆಳಗೆ ಬರೆಯಿರಿ.
 हिंदी (HINDI)
-चित्रों के अंक होते हैं, और बिना नामांकन वाले चित्रों को अंक नहीं मिलते। इन पाँच चित्रों का अभ्यास तब तक कीजिए जब तक हर एक लगभग तीन मिनट में न बन जाए: पादप कोशिका, माइटोकॉन्ड्रिया, तरल मोज़ेक मॉडल, कोशिका चक्र, और बीजांडन्यास के प्रकार। पेंसिल से बनाइए, चित्र बड़ा और साफ़ रखिए, नामांकन रेखाएँ सीधी और समानांतर खींचिए, और शीर्षक चित्र के नीचे लिखिए।</a:t>
+चित्रों के अंक होते हैं, और बिना नामांकन वाले चित्रों को अंक नहीं मिलते। इन चार चित्रों का अभ्यास तब तक कीजिए जब तक हर एक लगभग तीन मिनट में न बन जाए: पादप कोशिका, माइटोकॉन्ड्रिया, मेंढक का पाचन तंत्र, और कोशिका चक्र। पेंसिल से बनाइए, चित्र बड़ा और साफ़ रखिए, नामांकन रेखाएँ सीधी और समानांतर खींचिए, और शीर्षक चित्र के नीचे लिखिए।</a:t>
             </a:r>
             <a:endParaRPr lang="en-US" dirty="0"/>
           </a:p>
@@ -1506,11 +1512,11 @@
             <a:r>
               <a:rPr lang="en-US" dirty="0"/>
               <a:t>ENGLISH
-Here is a seven-day revision plan. Day one: Cell, the unit of life. Day two: cell diagrams and Biomolecules. Day three: Cell Cycle and Cell Division. Day four: Animal Kingdom. Day five: Living World, Biological Classification and Plant Kingdom. Day six: Morphology and Anatomy. Day seven: write a full mock paper in exam time and redraw all five diagrams.
+Here is a seven-day revision plan. Day one: Cell, the unit of life. Day two: cell diagrams and Biomolecules. Day three: Cell Cycle and Cell Division. Day four: Animal Kingdom and the frog. Day five: Living World, Biological Classification and Plant Kingdom. Day six: Morphology and Anatomy. Day seven: write a full mock paper in exam time and redraw all four diagrams.
 ಕನ್ನಡ (KANNADA)
-ಇಲ್ಲಿ ಏಳು ದಿನಗಳ ಪುನರಾವರ್ತನೆ ಯೋಜನೆ ಇದೆ. ಮೊದಲ ದಿನ: ಜೀವಕೋಶ, ಜೀವದ ಘಟಕ. ಎರಡನೇ ದಿನ: ಕೋಶದ ಚಿತ್ರಗಳು ಮತ್ತು ಜೈವಿಕ ಅಣುಗಳು. ಮೂರನೇ ದಿನ: ಜೀವಕೋಶ ಚಕ್ರ ಮತ್ತು ಕೋಶ ವಿಭಜನೆ. ನಾಲ್ಕನೇ ದಿನ: ಪ್ರಾಣಿ ಸಾಮ್ರಾಜ್ಯ. ಐದನೇ ದಿನ: ಜೀವ ಜಗತ್ತು, ಜೈವಿಕ ವರ್ಗೀಕರಣ ಮತ್ತು ಸಸ್ಯ ಸಾಮ್ರಾಜ್ಯ. ಆರನೇ ದಿನ: ರೂಪವಿಜ್ಞಾನ ಮತ್ತು ಅಂಗರಚನೆ. ಏಳನೇ ದಿನ: ಪರೀಕ್ಷಾ ಸಮಯದಲ್ಲಿ ಒಂದು ಪೂರ್ಣ ಮಾದರಿ ಪತ್ರಿಕೆ ಬರೆಯಿರಿ ಮತ್ತು ಐದೂ ಚಿತ್ರಗಳನ್ನು ಮತ್ತೆ ಬರೆಯಿರಿ.
+ಇಲ್ಲಿ ಏಳು ದಿನಗಳ ಪುನರಾವರ್ತನೆ ಯೋಜನೆ ಇದೆ. ಮೊದಲ ದಿನ: ಜೀವಕೋಶ, ಜೀವದ ಘಟಕ. ಎರಡನೇ ದಿನ: ಕೋಶದ ಚಿತ್ರಗಳು ಮತ್ತು ಜೈವಿಕ ಅಣುಗಳು. ಮೂರನೇ ದಿನ: ಜೀವಕೋಶ ಚಕ್ರ ಮತ್ತು ಕೋಶ ವಿಭಜನೆ. ನಾಲ್ಕನೇ ದಿನ: ಪ್ರಾಣಿ ಸಾಮ್ರಾಜ್ಯ ಮತ್ತು ಕಪ್ಪೆ. ಐದನೇ ದಿನ: ಜೀವ ಜಗತ್ತು, ಜೈವಿಕ ವರ್ಗೀಕರಣ ಮತ್ತು ಸಸ್ಯ ಸಾಮ್ರಾಜ್ಯ. ಆರನೇ ದಿನ: ರೂಪವಿಜ್ಞಾನ ಮತ್ತು ಅಂಗರಚನೆ. ಏಳನೇ ದಿನ: ಪರೀಕ್ಷಾ ಸಮಯದಲ್ಲಿ ಒಂದು ಪೂರ್ಣ ಮಾದರಿ ಪತ್ರಿಕೆ ಬರೆಯಿರಿ ಮತ್ತು ನಾಲ್ಕೂ ಚಿತ್ರಗಳನ್ನು ಮತ್ತೆ ಬರೆಯಿರಿ.
 हिंदी (HINDI)
-यह रही सात दिन की दोहराने की योजना। पहला दिन: कोशिका, जीवन की इकाई। दूसरा दिन: कोशिका के चित्र और जैव अणु। तीसरा दिन: कोशिका चक्र और कोशिका विभाजन। चौथा दिन: प्राणी जगत। पाँचवाँ दिन: जीव जगत, जैविक वर्गीकरण और पादप जगत। छठा दिन: आकारिकी और शारीरिकी। सातवाँ दिन: परीक्षा के समय में एक पूरा मॉडल पेपर लिखिए और पाँचों चित्र फिर से बनाइए।</a:t>
+यह रही सात दिन की दोहराने की योजना। पहला दिन: कोशिका, जीवन की इकाई। दूसरा दिन: कोशिका के चित्र और जैव अणु। तीसरा दिन: कोशिका चक्र और कोशिका विभाजन। चौथा दिन: प्राणी जगत और मेंढक। पाँचवाँ दिन: जीव जगत, जैविक वर्गीकरण और पादप जगत। छठा दिन: आकारिकी और शारीरिकी। सातवाँ दिन: परीक्षा के समय में एक पूरा मॉडल पेपर लिखिए और चारों चित्र फिर से बनाइए।</a:t>
             </a:r>
             <a:endParaRPr lang="en-US" dirty="0"/>
           </a:p>
@@ -1785,11 +1791,11 @@
             <a:r>
               <a:rPr lang="en-US" dirty="0"/>
               <a:t>ENGLISH
-This chart shows how many marks were asked from each chapter, counting the choice questions too. Cell: The Unit of Life is the biggest with 25 marks. Animal Kingdom follows with 16, then Biomolecules and Cell Cycle with 12 each. These four chapters together give 65 of the 105 marks asked, so study them first and study them deeply.
+This chart shows how many marks were asked from each chapter, counting the choice questions too. Cell: The Unit of Life is the biggest with 21 marks. Animal Kingdom follows with 16, then Biomolecules and Cell Cycle with 12 each. These four chapters together give 61 of the 105 marks asked, so study them first and study them deeply. Structural Organisation in Animals, the frog, adds 4 more marks.
 ಕನ್ನಡ (KANNADA)
-ಪ್ರತಿ ಅಧ್ಯಾಯದಿಂದ ಎಷ್ಟು ಅಂಕಗಳ ಪ್ರಶ್ನೆ ಕೇಳಲಾಗಿದೆ ಎಂಬುದನ್ನು ಈ ಚಾರ್ಟ್ ತೋರಿಸುತ್ತದೆ, ಆಯ್ಕೆ ಪ್ರಶ್ನೆಗಳನ್ನೂ ಸೇರಿಸಿ. ಜೀವಕೋಶ: ಜೀವದ ಘಟಕ ಅಧ್ಯಾಯದಿಂದ ಅತಿ ಹೆಚ್ಚು, 25 ಅಂಕಗಳು. ನಂತರ ಪ್ರಾಣಿ ಸಾಮ್ರಾಜ್ಯ 16, ಜೈವಿಕ ಅಣುಗಳು ಮತ್ತು ಜೀವಕೋಶ ಚಕ್ರ ತಲಾ 12. ಈ ನಾಲ್ಕು ಅಧ್ಯಾಯಗಳು ಒಟ್ಟು 105 ರಲ್ಲಿ 65 ಅಂಕಗಳನ್ನು ನೀಡುತ್ತವೆ. ಆದ್ದರಿಂದ ಇವುಗಳನ್ನು ಮೊದಲು ಮತ್ತು ಆಳವಾಗಿ ಓದಿ.
+ಪ್ರತಿ ಅಧ್ಯಾಯದಿಂದ ಎಷ್ಟು ಅಂಕಗಳ ಪ್ರಶ್ನೆ ಕೇಳಲಾಗಿದೆ ಎಂಬುದನ್ನು ಈ ಚಾರ್ಟ್ ತೋರಿಸುತ್ತದೆ, ಆಯ್ಕೆ ಪ್ರಶ್ನೆಗಳನ್ನೂ ಸೇರಿಸಿ. ಜೀವಕೋಶ: ಜೀವದ ಘಟಕ ಅಧ್ಯಾಯದಿಂದ ಅತಿ ಹೆಚ್ಚು, 21 ಅಂಕಗಳು. ನಂತರ ಪ್ರಾಣಿ ಸಾಮ್ರಾಜ್ಯ 16, ಜೈವಿಕ ಅಣುಗಳು ಮತ್ತು ಜೀವಕೋಶ ಚಕ್ರ ತಲಾ 12. ಈ ನಾಲ್ಕು ಅಧ್ಯಾಯಗಳು ಒಟ್ಟು 105 ರಲ್ಲಿ 61 ಅಂಕಗಳನ್ನು ನೀಡುತ್ತವೆ. ಆದ್ದರಿಂದ ಇವುಗಳನ್ನು ಮೊದಲು ಮತ್ತು ಆಳವಾಗಿ ಓದಿ. ಪ್ರಾಣಿಗಳ ರಚನಾತ್ಮಕ ಸಂಘಟನೆ, ಅಂದರೆ ಕಪ್ಪೆ, ಇನ್ನೂ 4 ಅಂಕಗಳನ್ನು ನೀಡುತ್ತದೆ.
 हिंदी (HINDI)
-यह चार्ट दिखाता है कि हर अध्याय से कितने अंकों के प्रश्न पूछे गए, विकल्प वाले प्रश्नों सहित। कोशिका: जीवन की इकाई सबसे बड़ा है, 25 अंक। उसके बाद प्राणी जगत 16, फिर जैव अणु और कोशिका चक्र 12-12। ये चार अध्याय मिलकर 105 में से 65 अंक देते हैं, इसलिए इन्हें सबसे पहले और गहराई से पढ़िए।</a:t>
+यह चार्ट दिखाता है कि हर अध्याय से कितने अंकों के प्रश्न पूछे गए, विकल्प वाले प्रश्नों सहित। कोशिका: जीवन की इकाई सबसे बड़ा है, 21 अंक। उसके बाद प्राणी जगत 16, फिर जैव अणु और कोशिका चक्र 12-12। ये चार अध्याय मिलकर 105 में से 61 अंक देते हैं, इसलिए इन्हें सबसे पहले और गहराई से पढ़िए। प्राणियों में संरचनात्मक संगठन, यानी मेंढक, से 4 अंक और आते हैं।</a:t>
             </a:r>
             <a:endParaRPr lang="en-US" dirty="0"/>
           </a:p>
@@ -2064,11 +2070,11 @@
             <a:r>
               <a:rPr lang="en-US" dirty="0"/>
               <a:t>ENGLISH
-Animal Kingdom carries 16 marks. For every phylum, remember three key features and two examples: Porifera, Ctenophora, Arthropoda, Mollusca, Echinodermata, Hemichordata and Chordata. The paper gives you features and asks you to name the phylum, so practise in both directions. Also prepare differences between chordates and non-chordates, and the characters of Class Mammalia. Remember: mammals are warm-blooded, so poikilothermous is not a mammalian character.
+Animal Kingdom carries 16 marks. For every phylum, remember three key features and two examples: Porifera, Ctenophora, Arthropoda, Mollusca, Echinodermata, Hemichordata and Chordata. The paper gives you features and asks you to name the phylum, so practise in both directions. Also prepare differences between chordates and non-chordates, and the characters of Class Mammalia. Remember: mammals are warm-blooded, so poikilothermous is not a mammalian character. From Structural Organisation in Animals, 4 marks, learn the frog: hibernation is its winter sleep, aestivation its summer sleep, and practise the labelled diagram of its digestive system.
 ಕನ್ನಡ (KANNADA)
-ಪ್ರಾಣಿ ಸಾಮ್ರಾಜ್ಯಕ್ಕೆ 16 ಅಂಕಗಳು. ಪ್ರತಿ ವಂಶಕ್ಕೆ ಮೂರು ಪ್ರಮುಖ ಲಕ್ಷಣಗಳು ಮತ್ತು ಎರಡು ಉದಾಹರಣೆಗಳನ್ನು ನೆನಪಿಡಿ: ಪೊರಿಫೆರಾ, ಟೀನೋಫೊರಾ, ಆರ್ತ್ರೋಪೋಡಾ, ಮೊಲಸ್ಕಾ, ಎಕೈನೋಡರ್ಮೇಟಾ, ಹೆಮಿಕಾರ್ಡೇಟಾ ಮತ್ತು ಕಾರ್ಡೇಟಾ. ಪ್ರಶ್ನೆಪತ್ರಿಕೆ ಲಕ್ಷಣಗಳನ್ನು ಕೊಟ್ಟು ವಂಶದ ಹೆಸರು ಕೇಳುತ್ತದೆ, ಆದ್ದರಿಂದ ಎರಡೂ ದಿಕ್ಕಿನಲ್ಲಿ ಅಭ್ಯಾಸ ಮಾಡಿ. ಕಾರ್ಡೇಟ್ ಮತ್ತು ಅಕಾರ್ಡೇಟ್‌ಗಳ ವ್ಯತ್ಯಾಸಗಳು ಹಾಗೂ ಸಸ್ತನಿ ವರ್ಗದ ಲಕ್ಷಣಗಳನ್ನು ಸಿದ್ಧಪಡಿಸಿ. ನೆನಪಿಡಿ: ಸಸ್ತನಿಗಳು ಉಷ್ಣರಕ್ತ ಪ್ರಾಣಿಗಳು.
+ಪ್ರಾಣಿ ಸಾಮ್ರಾಜ್ಯಕ್ಕೆ 16 ಅಂಕಗಳು. ಪ್ರತಿ ವಂಶಕ್ಕೆ ಮೂರು ಪ್ರಮುಖ ಲಕ್ಷಣಗಳು ಮತ್ತು ಎರಡು ಉದಾಹರಣೆಗಳನ್ನು ನೆನಪಿಡಿ: ಪೊರಿಫೆರಾ, ಟೀನೋಫೊರಾ, ಆರ್ತ್ರೋಪೋಡಾ, ಮೊಲಸ್ಕಾ, ಎಕೈನೋಡರ್ಮೇಟಾ, ಹೆಮಿಕಾರ್ಡೇಟಾ ಮತ್ತು ಕಾರ್ಡೇಟಾ. ಪ್ರಶ್ನೆಪತ್ರಿಕೆ ಲಕ್ಷಣಗಳನ್ನು ಕೊಟ್ಟು ವಂಶದ ಹೆಸರು ಕೇಳುತ್ತದೆ, ಆದ್ದರಿಂದ ಎರಡೂ ದಿಕ್ಕಿನಲ್ಲಿ ಅಭ್ಯಾಸ ಮಾಡಿ. ಕಾರ್ಡೇಟ್ ಮತ್ತು ಅಕಾರ್ಡೇಟ್‌ಗಳ ವ್ಯತ್ಯಾಸಗಳು ಹಾಗೂ ಸಸ್ತನಿ ವರ್ಗದ ಲಕ್ಷಣಗಳನ್ನು ಸಿದ್ಧಪಡಿಸಿ. ನೆನಪಿಡಿ: ಸಸ್ತನಿಗಳು ಉಷ್ಣರಕ್ತ ಪ್ರಾಣಿಗಳು. ಪ್ರಾಣಿಗಳ ರಚನಾತ್ಮಕ ಸಂಘಟನೆಯಿಂದ, 4 ಅಂಕಗಳು, ಕಪ್ಪೆಯನ್ನು ಕಲಿಯಿರಿ: ಹೈಬರ್ನೇಶನ್ ಚಳಿಗಾಲದ ನಿದ್ರೆ, ಈಸ್ಟಿವೇಶನ್ ಬೇಸಿಗೆಯ ನಿದ್ರೆ; ಕಪ್ಪೆಯ ಜೀರ್ಣಾಂಗ ವ್ಯವಸ್ಥೆಯ ಹೆಸರಿಸಿದ ಚಿತ್ರವನ್ನು ಅಭ್ಯಾಸ ಮಾಡಿ.
 हिंदी (HINDI)
-प्राणी जगत में 16 अंक हैं। हर संघ की तीन मुख्य विशेषताएँ और दो उदाहरण याद रखिए: पोरीफेरा, टीनोफोरा, आर्थ्रोपोडा, मोलस्का, इकाइनोडर्मेटा, हेमीकॉर्डेटा और कॉर्डेटा। पेपर विशेषताएँ देकर संघ का नाम पूछता है, इसलिए दोनों तरफ से अभ्यास कीजिए। कॉर्डेट और नॉन-कॉर्डेट के अंतर, और स्तनधारी वर्ग की विशेषताएँ भी तैयार कीजिए। याद रखिए: स्तनधारी नियततापी होते हैं।</a:t>
+प्राणी जगत में 16 अंक हैं। हर संघ की तीन मुख्य विशेषताएँ और दो उदाहरण याद रखिए: पोरीफेरा, टीनोफोरा, आर्थ्रोपोडा, मोलस्का, इकाइनोडर्मेटा, हेमीकॉर्डेटा और कॉर्डेटा। पेपर विशेषताएँ देकर संघ का नाम पूछता है, इसलिए दोनों तरफ से अभ्यास कीजिए। कॉर्डेट और नॉन-कॉर्डेट के अंतर, और स्तनधारी वर्ग की विशेषताएँ भी तैयार कीजिए। याद रखिए: स्तनधारी नियततापी होते हैं। प्राणियों में संरचनात्मक संगठन से, 4 अंक, मेंढक पढ़िए: शीतनिद्रा सर्दियों की नींद है और ग्रीष्मनिद्रा गर्मियों की नींद; मेंढक के पाचन तंत्र का नामांकित चित्र अभ्यास कीजिए।</a:t>
             </a:r>
             <a:endParaRPr lang="en-US" dirty="0"/>
           </a:p>
@@ -2157,11 +2163,11 @@
             <a:r>
               <a:rPr lang="en-US" dirty="0"/>
               <a:t>ENGLISH
-Morphology and Anatomy of flowering plants. Practise placentation with five small labelled diagrams and an example for each: marginal in pea, axile in tomato and lemon, parietal in mustard, free central in Dianthus, and basal in sunflower. Learn the types of phyllotaxy and venation, and remember that the edible part of mango is the mesocarp. From anatomy, prepare the epidermal tissue system with stomata, guard cells and root hairs, and the differences between open and closed vascular bundles.
+Morphology and Anatomy of flowering plants. Learn the five types of placentation with an example for each: marginal in pea, axile in tomato and lemon, parietal in mustard, free central in Dianthus, and basal in sunflower. Learn the types of phyllotaxy and venation, and remember that the edible part of mango is the mesocarp. From anatomy, prepare the epidermal tissue system with stomata, guard cells and root hairs, and the differences between open and closed vascular bundles.
 ಕನ್ನಡ (KANNADA)
-ಆವೃತಬೀಜ ಸಸ್ಯಗಳ ರೂಪವಿಜ್ಞಾನ ಮತ್ತು ಅಂಗರಚನೆ. ಬೀಜಾಂಡ ವಿನ್ಯಾಸವನ್ನು ಐದು ಸಣ್ಣ ಹೆಸರಿಸಿದ ಚಿತ್ರಗಳು ಮತ್ತು ತಲಾ ಒಂದು ಉದಾಹರಣೆಯೊಂದಿಗೆ ಅಭ್ಯಾಸ ಮಾಡಿ: ಬಟಾಣಿಯಲ್ಲಿ ಅಂಚಿನ, ಟೊಮೆಟೊ ಮತ್ತು ನಿಂಬೆಯಲ್ಲಿ ಅಕ್ಷೀಯ, ಸಾಸಿವೆಯಲ್ಲಿ ಭಿತ್ತಿಯ, ಡಯಾಂಥಸ್‌ನಲ್ಲಿ ಮುಕ್ತ ಕೇಂದ್ರೀಯ, ಸೂರ್ಯಕಾಂತಿಯಲ್ಲಿ ತಳದ ವಿನ್ಯಾಸ. ಎಲೆ ಜೋಡಣೆ ಮತ್ತು ನಾಳ ವಿನ್ಯಾಸದ ವಿಧಗಳನ್ನು ಕಲಿಯಿರಿ. ಮಾವಿನ ತಿನ್ನುವ ಭಾಗ ಮಧ್ಯಫಲಭಿತ್ತಿ. ಅಂಗರಚನೆಯಿಂದ ಪತ್ರರಂಧ್ರ, ರಕ್ಷಕ ಕೋಶಗಳು ಮತ್ತು ಬೇರುಕೂದಲು ಇರುವ ಹೊರಚರ್ಮ ಅಂಗಾಂಶ ವ್ಯವಸ್ಥೆ, ಹಾಗೂ ತೆರೆದ ಮತ್ತು ಮುಚ್ಚಿದ ನಾಳಕಟ್ಟುಗಳ ವ್ಯತ್ಯಾಸಗಳನ್ನು ಸಿದ್ಧಪಡಿಸಿ.
+ಆವೃತಬೀಜ ಸಸ್ಯಗಳ ರೂಪವಿಜ್ಞಾನ ಮತ್ತು ಅಂಗರಚನೆ. ಬೀಜಾಂಡ ವಿನ್ಯಾಸದ ಐದು ವಿಧಗಳನ್ನು ತಲಾ ಒಂದು ಉದಾಹರಣೆಯೊಂದಿಗೆ ಕಲಿಯಿರಿ: ಬಟಾಣಿಯಲ್ಲಿ ಅಂಚಿನ, ಟೊಮೆಟೊ ಮತ್ತು ನಿಂಬೆಯಲ್ಲಿ ಅಕ್ಷೀಯ, ಸಾಸಿವೆಯಲ್ಲಿ ಭಿತ್ತಿಯ, ಡಯಾಂಥಸ್‌ನಲ್ಲಿ ಮುಕ್ತ ಕೇಂದ್ರೀಯ, ಸೂರ್ಯಕಾಂತಿಯಲ್ಲಿ ತಳದ ವಿನ್ಯಾಸ. ಎಲೆ ಜೋಡಣೆ ಮತ್ತು ನಾಳ ವಿನ್ಯಾಸದ ವಿಧಗಳನ್ನು ಕಲಿಯಿರಿ. ಮಾವಿನ ತಿನ್ನುವ ಭಾಗ ಮಧ್ಯಫಲಭಿತ್ತಿ. ಅಂಗರಚನೆಯಿಂದ ಪತ್ರರಂಧ್ರ, ರಕ್ಷಕ ಕೋಶಗಳು ಮತ್ತು ಬೇರುಕೂದಲು ಇರುವ ಹೊರಚರ್ಮ ಅಂಗಾಂಶ ವ್ಯವಸ್ಥೆ, ಹಾಗೂ ತೆರೆದ ಮತ್ತು ಮುಚ್ಚಿದ ನಾಳಕಟ್ಟುಗಳ ವ್ಯತ್ಯಾಸಗಳನ್ನು ಸಿದ್ಧಪಡಿಸಿ.
 हिंदी (HINDI)
-पुष्पी पादपों की आकारिकी और शारीरिकी। बीजांडन्यास को पाँच छोटे नामांकित चित्रों और हर एक के उदाहरण के साथ अभ्यास कीजिए: मटर में सीमांत, टमाटर और नींबू में स्तंभीय, सरसों में भित्तीय, डायंथस में मुक्त स्तंभीय, और सूरजमुखी में आधारी। पर्णविन्यास और शिराविन्यास के प्रकार सीखिए, और याद रखिए कि आम का खाने योग्य भाग मध्यफलभित्ति है। शारीरिकी से रंध्र, द्वार कोशिकाएँ और मूलरोम वाला बाह्यत्वचीय ऊतक तंत्र, और खुले व बंद संवहन बंडलों के अंतर तैयार कीजिए।</a:t>
+पुष्पी पादपों की आकारिकी और शारीरिकी। बीजांडन्यास के पाँच प्रकार हर एक के उदाहरण के साथ सीखिए: मटर में सीमांत, टमाटर और नींबू में स्तंभीय, सरसों में भित्तीय, डायंथस में मुक्त स्तंभीय, और सूरजमुखी में आधारी। पर्णविन्यास और शिराविन्यास के प्रकार सीखिए, और याद रखिए कि आम का खाने योग्य भाग मध्यफलभित्ति है। शारीरिकी से रंध्र, द्वार कोशिकाएँ और मूलरोम वाला बाह्यत्वचीय ऊतक तंत्र, और खुले व बंद संवहन बंडलों के अंतर तैयार कीजिए।</a:t>
             </a:r>
             <a:endParaRPr lang="en-US" dirty="0"/>
           </a:p>
@@ -2250,11 +2256,11 @@
             <a:r>
               <a:rPr lang="en-US" dirty="0"/>
               <a:t>ENGLISH
-Cell: The Unit of Life is the highest-scoring chapter with 25 marks. Prepare the prokaryotic cell and mesosomes, plant cell versus animal cell, the fluid mosaic model of the cell membrane, the cell wall, the endomembrane system, mitochondria, plastids, ribosomes and the nucleus with the nucleolus. Many questions ask you to name the organelle where a structure is found, such as cristae in mitochondria, thylakoids in chloroplasts, cisternae in the Golgi body and the tonoplast around the vacuole.
+Cell: The Unit of Life is the highest-scoring chapter with 21 marks. Prepare the prokaryotic cell and mesosomes, plant cell versus animal cell, the fluid mosaic model of the cell membrane, the cell wall, the endomembrane system, mitochondria, plastids, ribosomes and the nucleus with the nucleolus. Many questions ask you to name the organelle where a structure is found, such as cristae in mitochondria, thylakoids in chloroplasts, cisternae in the Golgi body and the tonoplast around the vacuole.
 ಕನ್ನಡ (KANNADA)
-ಜೀವಕೋಶ: ಜೀವದ ಘಟಕ ಅತಿ ಹೆಚ್ಚು ಅಂಕದ ಅಧ್ಯಾಯ, 25 ಅಂಕಗಳು. ಆದಿಕೋಶ ಮತ್ತು ಮೀಸೋಸೋಮ್‌ಗಳು, ಸಸ್ಯಕೋಶ ಮತ್ತು ಪ್ರಾಣಿಕೋಶದ ವ್ಯತ್ಯಾಸ, ಕೋಶಪೊರೆಯ ದ್ರವ ಮೊಸಾಯಿಕ್ ಮಾದರಿ, ಕೋಶಭಿತ್ತಿ, ಒಳಪೊರೆ ವ್ಯವಸ್ಥೆ, ಮೈಟೊಕಾಂಡ್ರಿಯಾ, ಪ್ಲಾಸ್ಟಿಡ್‌ಗಳು, ರೈಬೋಸೋಮ್‌ಗಳು ಮತ್ತು ಕೋಶಕೇಂದ್ರಕವನ್ನು ಕೇಂದ್ರಕದ ಜೊತೆ ಸಿದ್ಧಪಡಿಸಿ. ಒಂದು ರಚನೆ ಯಾವ ಕೋಶಾಂಗದಲ್ಲಿದೆ ಎಂದು ಕೇಳುವ ಪ್ರಶ್ನೆಗಳು ಹೆಚ್ಚು: ಕ್ರಿಸ್ಟೇ ಮೈಟೊಕಾಂಡ್ರಿಯಾದಲ್ಲಿ, ಥೈಲಕಾಯ್ಡ್ ಹರಿತ್ತಿಲವಕದಲ್ಲಿ, ಸಿಸ್ಟರ್ನೇ ಗಾಲ್ಗಿ ಕಾಯದಲ್ಲಿ, ಟೋನೋಪ್ಲಾಸ್ಟ್ ರಸದಾನಿಯ ಸುತ್ತ.
+ಜೀವಕೋಶ: ಜೀವದ ಘಟಕ ಅತಿ ಹೆಚ್ಚು ಅಂಕದ ಅಧ್ಯಾಯ, 21 ಅಂಕಗಳು. ಆದಿಕೋಶ ಮತ್ತು ಮೀಸೋಸೋಮ್‌ಗಳು, ಸಸ್ಯಕೋಶ ಮತ್ತು ಪ್ರಾಣಿಕೋಶದ ವ್ಯತ್ಯಾಸ, ಕೋಶಪೊರೆಯ ದ್ರವ ಮೊಸಾಯಿಕ್ ಮಾದರಿ, ಕೋಶಭಿತ್ತಿ, ಒಳಪೊರೆ ವ್ಯವಸ್ಥೆ, ಮೈಟೊಕಾಂಡ್ರಿಯಾ, ಪ್ಲಾಸ್ಟಿಡ್‌ಗಳು, ರೈಬೋಸೋಮ್‌ಗಳು ಮತ್ತು ಕೋಶಕೇಂದ್ರಕವನ್ನು ಕೇಂದ್ರಕದ ಜೊತೆ ಸಿದ್ಧಪಡಿಸಿ. ಒಂದು ರಚನೆ ಯಾವ ಕೋಶಾಂಗದಲ್ಲಿದೆ ಎಂದು ಕೇಳುವ ಪ್ರಶ್ನೆಗಳು ಹೆಚ್ಚು: ಕ್ರಿಸ್ಟೇ ಮೈಟೊಕಾಂಡ್ರಿಯಾದಲ್ಲಿ, ಥೈಲಕಾಯ್ಡ್ ಹರಿತ್ತಿಲವಕದಲ್ಲಿ, ಸಿಸ್ಟರ್ನೇ ಗಾಲ್ಗಿ ಕಾಯದಲ್ಲಿ, ಟೋನೋಪ್ಲಾಸ್ಟ್ ರಸದಾನಿಯ ಸುತ್ತ.
 हिंदी (HINDI)
-कोशिका: जीवन की इकाई सबसे अधिक अंकों वाला अध्याय है, 25 अंक। प्रोकैरियोटिक कोशिका और मीसोसोम, पादप और जंतु कोशिका का अंतर, कोशिका झिल्ली का तरल मोज़ेक मॉडल, कोशिका भित्ति, अंतःझिल्ली तंत्र, माइटोकॉन्ड्रिया, लवक, राइबोसोम, और केंद्रिक सहित केंद्रक तैयार कीजिए। कई प्रश्न पूछते हैं कि कोई संरचना किस कोशिकांग में मिलती है: क्रिस्टी माइटोकॉन्ड्रिया में, थायलाकॉइड हरितलवक में, सिस्टर्नी गॉल्जी काय में, और टोनोप्लास्ट रिक्तिका के चारों ओर।</a:t>
+कोशिका: जीवन की इकाई सबसे अधिक अंकों वाला अध्याय है, 21 अंक। प्रोकैरियोटिक कोशिका और मीसोसोम, पादप और जंतु कोशिका का अंतर, कोशिका झिल्ली का तरल मोज़ेक मॉडल, कोशिका भित्ति, अंतःझिल्ली तंत्र, माइटोकॉन्ड्रिया, लवक, राइबोसोम, और केंद्रिक सहित केंद्रक तैयार कीजिए। कई प्रश्न पूछते हैं कि कोई संरचना किस कोशिकांग में मिलती है: क्रिस्टी माइटोकॉन्ड्रिया में, थायलाकॉइड हरितलवक में, सिस्टर्नी गॉल्जी काय में, और टोनोप्लास्ट रिक्तिका के चारों ओर।</a:t>
             </a:r>
             <a:endParaRPr lang="en-US" dirty="0"/>
           </a:p>
@@ -4136,7 +4142,7 @@
                   <a:schemeClr val="tx1"/>
                 </a:solidFill>
               </a:rPr>
-              <a:t>Master these five diagrams</a:t>
+              <a:t>Master these four diagrams</a:t>
             </a:r>
             <a:endParaRPr lang="en-US" sz="3400" dirty="0"/>
           </a:p>
@@ -4151,11 +4157,11 @@
         <p:spPr>
           <a:xfrm>
             <a:off x="548640" y="1371600"/>
-            <a:ext cx="2066544" cy="2240280"/>
+            <a:ext cx="2633472" cy="2240280"/>
           </a:xfrm>
           <a:prstGeom prst="roundRect">
             <a:avLst>
-              <a:gd name="adj" fmla="val 5310"/>
+              <a:gd name="adj" fmla="val 4898"/>
             </a:avLst>
           </a:prstGeom>
           <a:solidFill>
@@ -4172,7 +4178,7 @@
         </p:nvSpPr>
         <p:spPr>
           <a:xfrm>
-            <a:off x="1170432" y="1645920"/>
+            <a:off x="1453896" y="1645920"/>
             <a:ext cx="822960" cy="822960"/>
           </a:xfrm>
           <a:prstGeom prst="ellipse">
@@ -4200,7 +4206,7 @@
         </p:blipFill>
         <p:spPr>
           <a:xfrm>
-            <a:off x="1367942" y="1843430"/>
+            <a:off x="1651406" y="1843430"/>
             <a:ext cx="427939" cy="427939"/>
           </a:xfrm>
           <a:prstGeom prst="rect">
@@ -4217,7 +4223,7 @@
         <p:spPr>
           <a:xfrm>
             <a:off x="685800" y="2560320"/>
-            <a:ext cx="1792224" cy="548640"/>
+            <a:ext cx="2359152" cy="548640"/>
           </a:xfrm>
           <a:prstGeom prst="rect">
             <a:avLst/>
@@ -4253,7 +4259,7 @@
         <p:spPr>
           <a:xfrm>
             <a:off x="685800" y="3108960"/>
-            <a:ext cx="1792224" cy="320040"/>
+            <a:ext cx="2359152" cy="320040"/>
           </a:xfrm>
           <a:prstGeom prst="rect">
             <a:avLst/>
@@ -4288,12 +4294,12 @@
         </p:nvSpPr>
         <p:spPr>
           <a:xfrm>
-            <a:off x="2798064" y="1371600"/>
-            <a:ext cx="2066544" cy="2240280"/>
+            <a:off x="3364992" y="1371600"/>
+            <a:ext cx="2633472" cy="2240280"/>
           </a:xfrm>
           <a:prstGeom prst="roundRect">
             <a:avLst>
-              <a:gd name="adj" fmla="val 5310"/>
+              <a:gd name="adj" fmla="val 4898"/>
             </a:avLst>
           </a:prstGeom>
           <a:solidFill>
@@ -4310,7 +4316,7 @@
         </p:nvSpPr>
         <p:spPr>
           <a:xfrm>
-            <a:off x="3419856" y="1645920"/>
+            <a:off x="4270248" y="1645920"/>
             <a:ext cx="822960" cy="822960"/>
           </a:xfrm>
           <a:prstGeom prst="ellipse">
@@ -4338,7 +4344,7 @@
         </p:blipFill>
         <p:spPr>
           <a:xfrm>
-            <a:off x="3617366" y="1843430"/>
+            <a:off x="4467758" y="1843430"/>
             <a:ext cx="427939" cy="427939"/>
           </a:xfrm>
           <a:prstGeom prst="rect">
@@ -4354,8 +4360,8 @@
         </p:nvSpPr>
         <p:spPr>
           <a:xfrm>
-            <a:off x="2935224" y="2560320"/>
-            <a:ext cx="1792224" cy="548640"/>
+            <a:off x="3502152" y="2560320"/>
+            <a:ext cx="2359152" cy="548640"/>
           </a:xfrm>
           <a:prstGeom prst="rect">
             <a:avLst/>
@@ -4390,8 +4396,8 @@
         </p:nvSpPr>
         <p:spPr>
           <a:xfrm>
-            <a:off x="2935224" y="3108960"/>
-            <a:ext cx="1792224" cy="320040"/>
+            <a:off x="3502152" y="3108960"/>
+            <a:ext cx="2359152" cy="320040"/>
           </a:xfrm>
           <a:prstGeom prst="rect">
             <a:avLst/>
@@ -4420,18 +4426,18 @@
       </p:sp>
       <p:sp>
         <p:nvSpPr>
-          <p:cNvPr id="13" name="Fluid mosaic model card"/>
+          <p:cNvPr id="13" name="Frog digestive system card"/>
           <p:cNvSpPr/>
           <p:nvPr/>
         </p:nvSpPr>
         <p:spPr>
           <a:xfrm>
-            <a:off x="5047488" y="1371600"/>
-            <a:ext cx="2066544" cy="2240280"/>
+            <a:off x="6181344" y="1371600"/>
+            <a:ext cx="2633472" cy="2240280"/>
           </a:xfrm>
           <a:prstGeom prst="roundRect">
             <a:avLst>
-              <a:gd name="adj" fmla="val 5310"/>
+              <a:gd name="adj" fmla="val 4898"/>
             </a:avLst>
           </a:prstGeom>
           <a:solidFill>
@@ -4442,13 +4448,13 @@
       </p:sp>
       <p:sp>
         <p:nvSpPr>
-          <p:cNvPr id="14" name="Fluid mosaic model circle"/>
+          <p:cNvPr id="14" name="Frog digestive system circle"/>
           <p:cNvSpPr/>
           <p:nvPr/>
         </p:nvSpPr>
         <p:spPr>
           <a:xfrm>
-            <a:off x="5669280" y="1645920"/>
+            <a:off x="7086600" y="1645920"/>
             <a:ext cx="822960" cy="822960"/>
           </a:xfrm>
           <a:prstGeom prst="ellipse">
@@ -4462,7 +4468,7 @@
       </p:sp>
       <p:pic>
         <p:nvPicPr>
-          <p:cNvPr id="15" name="Fluid mosaic model icon" descr="preencoded.png">    </p:cNvPr>
+          <p:cNvPr id="15" name="Frog digestive system icon" descr="preencoded.png">    </p:cNvPr>
           <p:cNvPicPr>
             <a:picLocks noChangeAspect="1"/>
           </p:cNvPicPr>
@@ -4476,7 +4482,7 @@
         </p:blipFill>
         <p:spPr>
           <a:xfrm>
-            <a:off x="5866790" y="1843430"/>
+            <a:off x="7284110" y="1843430"/>
             <a:ext cx="427939" cy="427939"/>
           </a:xfrm>
           <a:prstGeom prst="rect">
@@ -4486,14 +4492,14 @@
       </p:pic>
       <p:sp>
         <p:nvSpPr>
-          <p:cNvPr id="16" name="Fluid mosaic model name"/>
-          <p:cNvSpPr txBox="1"/>
-          <p:nvPr/>
-        </p:nvSpPr>
-        <p:spPr>
-          <a:xfrm>
-            <a:off x="5184648" y="2560320"/>
-            <a:ext cx="1792224" cy="548640"/>
+          <p:cNvPr id="16" name="Frog digestive system name"/>
+          <p:cNvSpPr txBox="1"/>
+          <p:nvPr/>
+        </p:nvSpPr>
+        <p:spPr>
+          <a:xfrm>
+            <a:off x="6318504" y="2560320"/>
+            <a:ext cx="2359152" cy="548640"/>
           </a:xfrm>
           <a:prstGeom prst="rect">
             <a:avLst/>
@@ -4514,7 +4520,7 @@
                   <a:schemeClr val="tx1"/>
                 </a:solidFill>
               </a:rPr>
-              <a:t>Fluid mosaic model</a:t>
+              <a:t>Frog digestive system</a:t>
             </a:r>
             <a:endParaRPr lang="en-US" sz="1600" dirty="0"/>
           </a:p>
@@ -4522,14 +4528,14 @@
       </p:sp>
       <p:sp>
         <p:nvSpPr>
-          <p:cNvPr id="17" name="Fluid mosaic model chapter"/>
-          <p:cNvSpPr txBox="1"/>
-          <p:nvPr/>
-        </p:nvSpPr>
-        <p:spPr>
-          <a:xfrm>
-            <a:off x="5184648" y="3108960"/>
-            <a:ext cx="1792224" cy="320040"/>
+          <p:cNvPr id="17" name="Frog digestive system chapter"/>
+          <p:cNvSpPr txBox="1"/>
+          <p:nvPr/>
+        </p:nvSpPr>
+        <p:spPr>
+          <a:xfrm>
+            <a:off x="6318504" y="3108960"/>
+            <a:ext cx="2359152" cy="320040"/>
           </a:xfrm>
           <a:prstGeom prst="rect">
             <a:avLst/>
@@ -4550,7 +4556,7 @@
                   <a:schemeClr val="accent1"/>
                 </a:solidFill>
               </a:rPr>
-              <a:t>Ch 8</a:t>
+              <a:t>Ch 7</a:t>
             </a:r>
             <a:endParaRPr lang="en-US" sz="1300" dirty="0"/>
           </a:p>
@@ -4564,12 +4570,12 @@
         </p:nvSpPr>
         <p:spPr>
           <a:xfrm>
-            <a:off x="7296912" y="1371600"/>
-            <a:ext cx="2066544" cy="2240280"/>
+            <a:off x="8997696" y="1371600"/>
+            <a:ext cx="2633472" cy="2240280"/>
           </a:xfrm>
           <a:prstGeom prst="roundRect">
             <a:avLst>
-              <a:gd name="adj" fmla="val 5310"/>
+              <a:gd name="adj" fmla="val 4898"/>
             </a:avLst>
           </a:prstGeom>
           <a:solidFill>
@@ -4586,7 +4592,7 @@
         </p:nvSpPr>
         <p:spPr>
           <a:xfrm>
-            <a:off x="7918704" y="1645920"/>
+            <a:off x="9902952" y="1645920"/>
             <a:ext cx="822960" cy="822960"/>
           </a:xfrm>
           <a:prstGeom prst="ellipse">
@@ -4614,7 +4620,7 @@
         </p:blipFill>
         <p:spPr>
           <a:xfrm>
-            <a:off x="8116214" y="1843430"/>
+            <a:off x="10100462" y="1843430"/>
             <a:ext cx="427939" cy="427939"/>
           </a:xfrm>
           <a:prstGeom prst="rect">
@@ -4630,8 +4636,8 @@
         </p:nvSpPr>
         <p:spPr>
           <a:xfrm>
-            <a:off x="7434072" y="2560320"/>
-            <a:ext cx="1792224" cy="548640"/>
+            <a:off x="9134856" y="2560320"/>
+            <a:ext cx="2359152" cy="548640"/>
           </a:xfrm>
           <a:prstGeom prst="rect">
             <a:avLst/>
@@ -4666,8 +4672,8 @@
         </p:nvSpPr>
         <p:spPr>
           <a:xfrm>
-            <a:off x="7434072" y="3108960"/>
-            <a:ext cx="1792224" cy="320040"/>
+            <a:off x="9134856" y="3108960"/>
+            <a:ext cx="2359152" cy="320040"/>
           </a:xfrm>
           <a:prstGeom prst="rect">
             <a:avLst/>
@@ -4696,145 +4702,7 @@
       </p:sp>
       <p:sp>
         <p:nvSpPr>
-          <p:cNvPr id="23" name="Placentation types card"/>
-          <p:cNvSpPr/>
-          <p:nvPr/>
-        </p:nvSpPr>
-        <p:spPr>
-          <a:xfrm>
-            <a:off x="9546336" y="1371600"/>
-            <a:ext cx="2066544" cy="2240280"/>
-          </a:xfrm>
-          <a:prstGeom prst="roundRect">
-            <a:avLst>
-              <a:gd name="adj" fmla="val 5310"/>
-            </a:avLst>
-          </a:prstGeom>
-          <a:solidFill>
-            <a:srgbClr val="E8F3F1"/>
-          </a:solidFill>
-          <a:ln/>
-        </p:spPr>
-      </p:sp>
-      <p:sp>
-        <p:nvSpPr>
-          <p:cNvPr id="24" name="Placentation types circle"/>
-          <p:cNvSpPr/>
-          <p:nvPr/>
-        </p:nvSpPr>
-        <p:spPr>
-          <a:xfrm>
-            <a:off x="10168128" y="1645920"/>
-            <a:ext cx="822960" cy="822960"/>
-          </a:xfrm>
-          <a:prstGeom prst="ellipse">
-            <a:avLst/>
-          </a:prstGeom>
-          <a:solidFill>
-            <a:srgbClr val="FFFFFF"/>
-          </a:solidFill>
-          <a:ln/>
-        </p:spPr>
-      </p:sp>
-      <p:pic>
-        <p:nvPicPr>
-          <p:cNvPr id="25" name="Placentation types icon" descr="preencoded.png">    </p:cNvPr>
-          <p:cNvPicPr>
-            <a:picLocks noChangeAspect="1"/>
-          </p:cNvPicPr>
-          <p:nvPr/>
-        </p:nvPicPr>
-        <p:blipFill>
-          <a:blip r:embed="rId5"/>
-          <a:stretch>
-            <a:fillRect/>
-          </a:stretch>
-        </p:blipFill>
-        <p:spPr>
-          <a:xfrm>
-            <a:off x="10365638" y="1843430"/>
-            <a:ext cx="427939" cy="427939"/>
-          </a:xfrm>
-          <a:prstGeom prst="rect">
-            <a:avLst/>
-          </a:prstGeom>
-        </p:spPr>
-      </p:pic>
-      <p:sp>
-        <p:nvSpPr>
-          <p:cNvPr id="26" name="Placentation types name"/>
-          <p:cNvSpPr txBox="1"/>
-          <p:nvPr/>
-        </p:nvSpPr>
-        <p:spPr>
-          <a:xfrm>
-            <a:off x="9683496" y="2560320"/>
-            <a:ext cx="1792224" cy="548640"/>
-          </a:xfrm>
-          <a:prstGeom prst="rect">
-            <a:avLst/>
-          </a:prstGeom>
-          <a:noFill/>
-          <a:ln/>
-        </p:spPr>
-        <p:txBody>
-          <a:bodyPr wrap="square" lIns="0" tIns="0" rIns="0" bIns="0" rtlCol="0" anchor="ctr"/>
-          <a:lstStyle/>
-          <a:p>
-            <a:pPr algn="ctr" indent="0" marL="0">
-              <a:buNone/>
-            </a:pPr>
-            <a:r>
-              <a:rPr lang="en-US" sz="1600" b="1" dirty="0">
-                <a:solidFill>
-                  <a:schemeClr val="tx1"/>
-                </a:solidFill>
-              </a:rPr>
-              <a:t>Placentation types</a:t>
-            </a:r>
-            <a:endParaRPr lang="en-US" sz="1600" dirty="0"/>
-          </a:p>
-        </p:txBody>
-      </p:sp>
-      <p:sp>
-        <p:nvSpPr>
-          <p:cNvPr id="27" name="Placentation types chapter"/>
-          <p:cNvSpPr txBox="1"/>
-          <p:nvPr/>
-        </p:nvSpPr>
-        <p:spPr>
-          <a:xfrm>
-            <a:off x="9683496" y="3108960"/>
-            <a:ext cx="1792224" cy="320040"/>
-          </a:xfrm>
-          <a:prstGeom prst="rect">
-            <a:avLst/>
-          </a:prstGeom>
-          <a:noFill/>
-          <a:ln/>
-        </p:spPr>
-        <p:txBody>
-          <a:bodyPr wrap="square" lIns="0" tIns="0" rIns="0" bIns="0" rtlCol="0" anchor="ctr"/>
-          <a:lstStyle/>
-          <a:p>
-            <a:pPr algn="ctr" indent="0" marL="0">
-              <a:buNone/>
-            </a:pPr>
-            <a:r>
-              <a:rPr lang="en-US" sz="1300" dirty="0">
-                <a:solidFill>
-                  <a:schemeClr val="accent1"/>
-                </a:solidFill>
-              </a:rPr>
-              <a:t>Ch 5</a:t>
-            </a:r>
-            <a:endParaRPr lang="en-US" sz="1300" dirty="0"/>
-          </a:p>
-        </p:txBody>
-      </p:sp>
-      <p:sp>
-        <p:nvSpPr>
-          <p:cNvPr id="28" name="rule badge 1"/>
+          <p:cNvPr id="23" name="rule badge 1"/>
           <p:cNvSpPr/>
           <p:nvPr/>
         </p:nvSpPr>
@@ -4854,7 +4722,7 @@
       </p:sp>
       <p:sp>
         <p:nvSpPr>
-          <p:cNvPr id="29" name="rule number 1"/>
+          <p:cNvPr id="24" name="rule number 1"/>
           <p:cNvSpPr txBox="1"/>
           <p:nvPr/>
         </p:nvSpPr>
@@ -4890,7 +4758,7 @@
       </p:sp>
       <p:sp>
         <p:nvSpPr>
-          <p:cNvPr id="30" name="rule 1"/>
+          <p:cNvPr id="25" name="rule 1"/>
           <p:cNvSpPr txBox="1"/>
           <p:nvPr/>
         </p:nvSpPr>
@@ -4940,7 +4808,7 @@
       </p:sp>
       <p:sp>
         <p:nvSpPr>
-          <p:cNvPr id="31" name="rule badge 2"/>
+          <p:cNvPr id="26" name="rule badge 2"/>
           <p:cNvSpPr/>
           <p:nvPr/>
         </p:nvSpPr>
@@ -4960,7 +4828,7 @@
       </p:sp>
       <p:sp>
         <p:nvSpPr>
-          <p:cNvPr id="32" name="rule number 2"/>
+          <p:cNvPr id="27" name="rule number 2"/>
           <p:cNvSpPr txBox="1"/>
           <p:nvPr/>
         </p:nvSpPr>
@@ -4996,7 +4864,7 @@
       </p:sp>
       <p:sp>
         <p:nvSpPr>
-          <p:cNvPr id="33" name="rule 2"/>
+          <p:cNvPr id="28" name="rule 2"/>
           <p:cNvSpPr txBox="1"/>
           <p:nvPr/>
         </p:nvSpPr>
@@ -5046,7 +4914,7 @@
       </p:sp>
       <p:sp>
         <p:nvSpPr>
-          <p:cNvPr id="34" name="rule badge 3"/>
+          <p:cNvPr id="29" name="rule badge 3"/>
           <p:cNvSpPr/>
           <p:nvPr/>
         </p:nvSpPr>
@@ -5066,7 +4934,7 @@
       </p:sp>
       <p:sp>
         <p:nvSpPr>
-          <p:cNvPr id="35" name="rule number 3"/>
+          <p:cNvPr id="30" name="rule number 3"/>
           <p:cNvSpPr txBox="1"/>
           <p:nvPr/>
         </p:nvSpPr>
@@ -5102,7 +4970,7 @@
       </p:sp>
       <p:sp>
         <p:nvSpPr>
-          <p:cNvPr id="36" name="rule 3"/>
+          <p:cNvPr id="31" name="rule 3"/>
           <p:cNvSpPr txBox="1"/>
           <p:nvPr/>
         </p:nvSpPr>
@@ -5152,7 +5020,7 @@
       </p:sp>
       <p:sp>
         <p:nvSpPr>
-          <p:cNvPr id="37" name="rule badge 4"/>
+          <p:cNvPr id="32" name="rule badge 4"/>
           <p:cNvSpPr/>
           <p:nvPr/>
         </p:nvSpPr>
@@ -5172,7 +5040,7 @@
       </p:sp>
       <p:sp>
         <p:nvSpPr>
-          <p:cNvPr id="38" name="rule number 4"/>
+          <p:cNvPr id="33" name="rule number 4"/>
           <p:cNvSpPr txBox="1"/>
           <p:nvPr/>
         </p:nvSpPr>
@@ -5208,7 +5076,7 @@
       </p:sp>
       <p:sp>
         <p:nvSpPr>
-          <p:cNvPr id="39" name="rule 4"/>
+          <p:cNvPr id="34" name="rule 4"/>
           <p:cNvSpPr txBox="1"/>
           <p:nvPr/>
         </p:nvSpPr>
@@ -8919,7 +8787,7 @@
                   <a:schemeClr val="tx1"/>
                 </a:solidFill>
               </a:rPr>
-              <a:t>Animal Kingdom</a:t>
+              <a:t>Animal Kingdom + Frog</a:t>
             </a:r>
             <a:endParaRPr lang="en-US" sz="1500" dirty="0"/>
           </a:p>
@@ -8955,7 +8823,7 @@
                   <a:schemeClr val="tx2"/>
                 </a:solidFill>
               </a:rPr>
-              <a:t>Phyla, features, examples</a:t>
+              <a:t>Phyla, examples, frog (Ch 7)</a:t>
             </a:r>
             <a:endParaRPr lang="en-US" sz="1300" dirty="0"/>
           </a:p>
@@ -9462,7 +9330,7 @@
                   <a:srgbClr val="DCE4F0"/>
                 </a:solidFill>
               </a:rPr>
-              <a:t>Full paper in exam time + redraw all 5 diagrams</a:t>
+              <a:t>Full paper in exam time + redraw all 4 diagrams</a:t>
             </a:r>
             <a:endParaRPr lang="en-US" sz="1300" dirty="0"/>
           </a:p>
@@ -9730,7 +9598,7 @@
                   <a:srgbClr val="FFFFFF"/>
                 </a:solidFill>
               </a:rPr>
-              <a:t>Practise the 5 diagrams with labels</a:t>
+              <a:t>Practise the 4 diagrams with labels</a:t>
             </a:r>
             <a:endParaRPr lang="en-US" sz="2000" dirty="0"/>
           </a:p>
@@ -10971,7 +10839,7 @@
                 <a:ea typeface="Cambria" pitchFamily="34" charset="-122"/>
                 <a:cs typeface="Cambria" pitchFamily="34" charset="-120"/>
               </a:rPr>
-              <a:t>65</a:t>
+              <a:t>61</a:t>
             </a:r>
             <a:endParaRPr lang="en-US" sz="7200" dirty="0"/>
           </a:p>
@@ -12871,7 +12739,7 @@
                   <a:schemeClr val="tx1"/>
                 </a:solidFill>
               </a:rPr>
-              <a:t>Animal Kingdom</a:t>
+              <a:t>Animal Kingdom &amp; Structural Organisation in Animals</a:t>
             </a:r>
             <a:endParaRPr lang="en-US" sz="3400" dirty="0"/>
           </a:p>
@@ -12973,7 +12841,7 @@
                   <a:schemeClr val="accent1"/>
                 </a:solidFill>
               </a:rPr>
-              <a:t>Chapter 4</a:t>
+              <a:t>Chapters 4 &amp; 7</a:t>
             </a:r>
             <a:endParaRPr lang="en-US" sz="1500" dirty="0"/>
           </a:p>
@@ -13012,7 +12880,7 @@
                 <a:ea typeface="Cambria" pitchFamily="34" charset="-122"/>
                 <a:cs typeface="Cambria" pitchFamily="34" charset="-120"/>
               </a:rPr>
-              <a:t>16</a:t>
+              <a:t>20</a:t>
             </a:r>
             <a:endParaRPr lang="en-US" sz="8000" dirty="0"/>
           </a:p>
@@ -13134,12 +13002,12 @@
         </p:nvSpPr>
         <p:spPr>
           <a:xfrm>
-            <a:off x="4114800" y="2052828"/>
-            <a:ext cx="1554480" cy="566928"/>
+            <a:off x="4114800" y="1906524"/>
+            <a:ext cx="1554480" cy="493776"/>
           </a:xfrm>
           <a:prstGeom prst="roundRect">
             <a:avLst>
-              <a:gd name="adj" fmla="val 50000"/>
+              <a:gd name="adj" fmla="val 57407"/>
             </a:avLst>
           </a:prstGeom>
           <a:solidFill>
@@ -13161,8 +13029,8 @@
         </p:nvSpPr>
         <p:spPr>
           <a:xfrm>
-            <a:off x="4114800" y="2052828"/>
-            <a:ext cx="1554480" cy="566928"/>
+            <a:off x="4114800" y="1906524"/>
+            <a:ext cx="1554480" cy="493776"/>
           </a:xfrm>
           <a:prstGeom prst="rect">
             <a:avLst/>
@@ -13178,14 +13046,14 @@
               <a:buNone/>
             </a:pPr>
             <a:r>
-              <a:rPr lang="en-US" sz="1800" b="1" dirty="0">
+              <a:rPr lang="en-US" sz="1700" b="1" dirty="0">
                 <a:solidFill>
                   <a:schemeClr val="tx1"/>
                 </a:solidFill>
               </a:rPr>
               <a:t>Porifera</a:t>
             </a:r>
-            <a:endParaRPr lang="en-US" sz="1800" dirty="0"/>
+            <a:endParaRPr lang="en-US" sz="1700" dirty="0"/>
           </a:p>
         </p:txBody>
       </p:sp>
@@ -13197,12 +13065,12 @@
         </p:nvSpPr>
         <p:spPr>
           <a:xfrm>
-            <a:off x="5852160" y="2052828"/>
-            <a:ext cx="1783080" cy="566928"/>
+            <a:off x="5797296" y="1906524"/>
+            <a:ext cx="1783080" cy="493776"/>
           </a:xfrm>
           <a:prstGeom prst="roundRect">
             <a:avLst>
-              <a:gd name="adj" fmla="val 50000"/>
+              <a:gd name="adj" fmla="val 57407"/>
             </a:avLst>
           </a:prstGeom>
           <a:solidFill>
@@ -13224,8 +13092,8 @@
         </p:nvSpPr>
         <p:spPr>
           <a:xfrm>
-            <a:off x="5852160" y="2052828"/>
-            <a:ext cx="1783080" cy="566928"/>
+            <a:off x="5797296" y="1906524"/>
+            <a:ext cx="1783080" cy="493776"/>
           </a:xfrm>
           <a:prstGeom prst="rect">
             <a:avLst/>
@@ -13241,14 +13109,14 @@
               <a:buNone/>
             </a:pPr>
             <a:r>
-              <a:rPr lang="en-US" sz="1800" b="1" dirty="0">
+              <a:rPr lang="en-US" sz="1700" b="1" dirty="0">
                 <a:solidFill>
                   <a:schemeClr val="tx1"/>
                 </a:solidFill>
               </a:rPr>
               <a:t>Ctenophora</a:t>
             </a:r>
-            <a:endParaRPr lang="en-US" sz="1800" dirty="0"/>
+            <a:endParaRPr lang="en-US" sz="1700" dirty="0"/>
           </a:p>
         </p:txBody>
       </p:sp>
@@ -13260,12 +13128,12 @@
         </p:nvSpPr>
         <p:spPr>
           <a:xfrm>
-            <a:off x="7818120" y="2052828"/>
-            <a:ext cx="1783080" cy="566928"/>
+            <a:off x="7708392" y="1906524"/>
+            <a:ext cx="1783080" cy="493776"/>
           </a:xfrm>
           <a:prstGeom prst="roundRect">
             <a:avLst>
-              <a:gd name="adj" fmla="val 50000"/>
+              <a:gd name="adj" fmla="val 57407"/>
             </a:avLst>
           </a:prstGeom>
           <a:solidFill>
@@ -13287,8 +13155,8 @@
         </p:nvSpPr>
         <p:spPr>
           <a:xfrm>
-            <a:off x="7818120" y="2052828"/>
-            <a:ext cx="1783080" cy="566928"/>
+            <a:off x="7708392" y="1906524"/>
+            <a:ext cx="1783080" cy="493776"/>
           </a:xfrm>
           <a:prstGeom prst="rect">
             <a:avLst/>
@@ -13304,14 +13172,14 @@
               <a:buNone/>
             </a:pPr>
             <a:r>
-              <a:rPr lang="en-US" sz="1800" b="1" dirty="0">
+              <a:rPr lang="en-US" sz="1700" b="1" dirty="0">
                 <a:solidFill>
                   <a:schemeClr val="tx1"/>
                 </a:solidFill>
               </a:rPr>
               <a:t>Arthropoda</a:t>
             </a:r>
-            <a:endParaRPr lang="en-US" sz="1800" dirty="0"/>
+            <a:endParaRPr lang="en-US" sz="1700" dirty="0"/>
           </a:p>
         </p:txBody>
       </p:sp>
@@ -13323,12 +13191,12 @@
         </p:nvSpPr>
         <p:spPr>
           <a:xfrm>
-            <a:off x="9784080" y="2052828"/>
-            <a:ext cx="1554480" cy="566928"/>
+            <a:off x="9619488" y="1906524"/>
+            <a:ext cx="1554480" cy="493776"/>
           </a:xfrm>
           <a:prstGeom prst="roundRect">
             <a:avLst>
-              <a:gd name="adj" fmla="val 50000"/>
+              <a:gd name="adj" fmla="val 57407"/>
             </a:avLst>
           </a:prstGeom>
           <a:solidFill>
@@ -13350,8 +13218,8 @@
         </p:nvSpPr>
         <p:spPr>
           <a:xfrm>
-            <a:off x="9784080" y="2052828"/>
-            <a:ext cx="1554480" cy="566928"/>
+            <a:off x="9619488" y="1906524"/>
+            <a:ext cx="1554480" cy="493776"/>
           </a:xfrm>
           <a:prstGeom prst="rect">
             <a:avLst/>
@@ -13367,14 +13235,14 @@
               <a:buNone/>
             </a:pPr>
             <a:r>
-              <a:rPr lang="en-US" sz="1800" b="1" dirty="0">
+              <a:rPr lang="en-US" sz="1700" b="1" dirty="0">
                 <a:solidFill>
                   <a:schemeClr val="tx1"/>
                 </a:solidFill>
               </a:rPr>
               <a:t>Mollusca</a:t>
             </a:r>
-            <a:endParaRPr lang="en-US" sz="1800" dirty="0"/>
+            <a:endParaRPr lang="en-US" sz="1700" dirty="0"/>
           </a:p>
         </p:txBody>
       </p:sp>
@@ -13386,12 +13254,12 @@
         </p:nvSpPr>
         <p:spPr>
           <a:xfrm>
-            <a:off x="4114800" y="2802636"/>
-            <a:ext cx="2125980" cy="566928"/>
+            <a:off x="4114800" y="2528316"/>
+            <a:ext cx="2125980" cy="493776"/>
           </a:xfrm>
           <a:prstGeom prst="roundRect">
             <a:avLst>
-              <a:gd name="adj" fmla="val 50000"/>
+              <a:gd name="adj" fmla="val 57407"/>
             </a:avLst>
           </a:prstGeom>
           <a:solidFill>
@@ -13413,8 +13281,8 @@
         </p:nvSpPr>
         <p:spPr>
           <a:xfrm>
-            <a:off x="4114800" y="2802636"/>
-            <a:ext cx="2125980" cy="566928"/>
+            <a:off x="4114800" y="2528316"/>
+            <a:ext cx="2125980" cy="493776"/>
           </a:xfrm>
           <a:prstGeom prst="rect">
             <a:avLst/>
@@ -13430,14 +13298,14 @@
               <a:buNone/>
             </a:pPr>
             <a:r>
-              <a:rPr lang="en-US" sz="1800" b="1" dirty="0">
+              <a:rPr lang="en-US" sz="1700" b="1" dirty="0">
                 <a:solidFill>
                   <a:schemeClr val="tx1"/>
                 </a:solidFill>
               </a:rPr>
               <a:t>Echinodermata</a:t>
             </a:r>
-            <a:endParaRPr lang="en-US" sz="1800" dirty="0"/>
+            <a:endParaRPr lang="en-US" sz="1700" dirty="0"/>
           </a:p>
         </p:txBody>
       </p:sp>
@@ -13449,12 +13317,12 @@
         </p:nvSpPr>
         <p:spPr>
           <a:xfrm>
-            <a:off x="6423660" y="2802636"/>
-            <a:ext cx="2011680" cy="566928"/>
+            <a:off x="6368796" y="2528316"/>
+            <a:ext cx="2011680" cy="493776"/>
           </a:xfrm>
           <a:prstGeom prst="roundRect">
             <a:avLst>
-              <a:gd name="adj" fmla="val 50000"/>
+              <a:gd name="adj" fmla="val 57407"/>
             </a:avLst>
           </a:prstGeom>
           <a:solidFill>
@@ -13476,8 +13344,8 @@
         </p:nvSpPr>
         <p:spPr>
           <a:xfrm>
-            <a:off x="6423660" y="2802636"/>
-            <a:ext cx="2011680" cy="566928"/>
+            <a:off x="6368796" y="2528316"/>
+            <a:ext cx="2011680" cy="493776"/>
           </a:xfrm>
           <a:prstGeom prst="rect">
             <a:avLst/>
@@ -13493,14 +13361,14 @@
               <a:buNone/>
             </a:pPr>
             <a:r>
-              <a:rPr lang="en-US" sz="1800" b="1" dirty="0">
+              <a:rPr lang="en-US" sz="1700" b="1" dirty="0">
                 <a:solidFill>
                   <a:schemeClr val="tx1"/>
                 </a:solidFill>
               </a:rPr>
               <a:t>Hemichordata</a:t>
             </a:r>
-            <a:endParaRPr lang="en-US" sz="1800" dirty="0"/>
+            <a:endParaRPr lang="en-US" sz="1700" dirty="0"/>
           </a:p>
         </p:txBody>
       </p:sp>
@@ -13512,12 +13380,12 @@
         </p:nvSpPr>
         <p:spPr>
           <a:xfrm>
-            <a:off x="8618220" y="2802636"/>
-            <a:ext cx="1554480" cy="566928"/>
+            <a:off x="8508492" y="2528316"/>
+            <a:ext cx="1554480" cy="493776"/>
           </a:xfrm>
           <a:prstGeom prst="roundRect">
             <a:avLst>
-              <a:gd name="adj" fmla="val 50000"/>
+              <a:gd name="adj" fmla="val 57407"/>
             </a:avLst>
           </a:prstGeom>
           <a:solidFill>
@@ -13539,8 +13407,8 @@
         </p:nvSpPr>
         <p:spPr>
           <a:xfrm>
-            <a:off x="8618220" y="2802636"/>
-            <a:ext cx="1554480" cy="566928"/>
+            <a:off x="8508492" y="2528316"/>
+            <a:ext cx="1554480" cy="493776"/>
           </a:xfrm>
           <a:prstGeom prst="rect">
             <a:avLst/>
@@ -13556,14 +13424,14 @@
               <a:buNone/>
             </a:pPr>
             <a:r>
-              <a:rPr lang="en-US" sz="1800" b="1" dirty="0">
+              <a:rPr lang="en-US" sz="1700" b="1" dirty="0">
                 <a:solidFill>
                   <a:schemeClr val="tx1"/>
                 </a:solidFill>
               </a:rPr>
               <a:t>Chordata</a:t>
             </a:r>
-            <a:endParaRPr lang="en-US" sz="1800" dirty="0"/>
+            <a:endParaRPr lang="en-US" sz="1700" dirty="0"/>
           </a:p>
         </p:txBody>
       </p:sp>
@@ -13575,12 +13443,12 @@
         </p:nvSpPr>
         <p:spPr>
           <a:xfrm>
-            <a:off x="4114800" y="3552444"/>
-            <a:ext cx="3611880" cy="566928"/>
+            <a:off x="4114800" y="3150108"/>
+            <a:ext cx="3611880" cy="493776"/>
           </a:xfrm>
           <a:prstGeom prst="roundRect">
             <a:avLst>
-              <a:gd name="adj" fmla="val 50000"/>
+              <a:gd name="adj" fmla="val 57407"/>
             </a:avLst>
           </a:prstGeom>
           <a:solidFill>
@@ -13602,8 +13470,8 @@
         </p:nvSpPr>
         <p:spPr>
           <a:xfrm>
-            <a:off x="4114800" y="3552444"/>
-            <a:ext cx="3611880" cy="566928"/>
+            <a:off x="4114800" y="3150108"/>
+            <a:ext cx="3611880" cy="493776"/>
           </a:xfrm>
           <a:prstGeom prst="rect">
             <a:avLst/>
@@ -13619,14 +13487,14 @@
               <a:buNone/>
             </a:pPr>
             <a:r>
-              <a:rPr lang="en-US" sz="1800" b="1" dirty="0">
+              <a:rPr lang="en-US" sz="1700" b="1" dirty="0">
                 <a:solidFill>
                   <a:schemeClr val="tx1"/>
                 </a:solidFill>
               </a:rPr>
               <a:t>Chordates vs Non-chordates</a:t>
             </a:r>
-            <a:endParaRPr lang="en-US" sz="1800" dirty="0"/>
+            <a:endParaRPr lang="en-US" sz="1700" dirty="0"/>
           </a:p>
         </p:txBody>
       </p:sp>
@@ -13638,12 +13506,12 @@
         </p:nvSpPr>
         <p:spPr>
           <a:xfrm>
-            <a:off x="7909560" y="3552444"/>
-            <a:ext cx="2240280" cy="566928"/>
+            <a:off x="7854696" y="3150108"/>
+            <a:ext cx="2240280" cy="493776"/>
           </a:xfrm>
           <a:prstGeom prst="roundRect">
             <a:avLst>
-              <a:gd name="adj" fmla="val 50000"/>
+              <a:gd name="adj" fmla="val 57407"/>
             </a:avLst>
           </a:prstGeom>
           <a:solidFill>
@@ -13665,8 +13533,8 @@
         </p:nvSpPr>
         <p:spPr>
           <a:xfrm>
-            <a:off x="7909560" y="3552444"/>
-            <a:ext cx="2240280" cy="566928"/>
+            <a:off x="7854696" y="3150108"/>
+            <a:ext cx="2240280" cy="493776"/>
           </a:xfrm>
           <a:prstGeom prst="rect">
             <a:avLst/>
@@ -13682,20 +13550,146 @@
               <a:buNone/>
             </a:pPr>
             <a:r>
-              <a:rPr lang="en-US" sz="1800" b="1" dirty="0">
+              <a:rPr lang="en-US" sz="1700" b="1" dirty="0">
                 <a:solidFill>
                   <a:schemeClr val="tx1"/>
                 </a:solidFill>
               </a:rPr>
               <a:t>Class Mammalia</a:t>
             </a:r>
-            <a:endParaRPr lang="en-US" sz="1800" dirty="0"/>
-          </a:p>
-        </p:txBody>
-      </p:sp>
-      <p:sp>
-        <p:nvSpPr>
-          <p:cNvPr id="29" name="tip box"/>
+            <a:endParaRPr lang="en-US" sz="1700" dirty="0"/>
+          </a:p>
+        </p:txBody>
+      </p:sp>
+      <p:sp>
+        <p:nvSpPr>
+          <p:cNvPr id="29" name="topic chip 10"/>
+          <p:cNvSpPr/>
+          <p:nvPr/>
+        </p:nvSpPr>
+        <p:spPr>
+          <a:xfrm>
+            <a:off x="4114800" y="3771900"/>
+            <a:ext cx="4183380" cy="493776"/>
+          </a:xfrm>
+          <a:prstGeom prst="roundRect">
+            <a:avLst>
+              <a:gd name="adj" fmla="val 57407"/>
+            </a:avLst>
+          </a:prstGeom>
+          <a:solidFill>
+            <a:srgbClr val="F4F8F8"/>
+          </a:solidFill>
+          <a:ln w="12700">
+            <a:solidFill>
+              <a:srgbClr val="D9E2E1"/>
+            </a:solidFill>
+            <a:prstDash val="solid"/>
+          </a:ln>
+        </p:spPr>
+      </p:sp>
+      <p:sp>
+        <p:nvSpPr>
+          <p:cNvPr id="30" name="topic 10"/>
+          <p:cNvSpPr txBox="1"/>
+          <p:nvPr/>
+        </p:nvSpPr>
+        <p:spPr>
+          <a:xfrm>
+            <a:off x="4114800" y="3771900"/>
+            <a:ext cx="4183380" cy="493776"/>
+          </a:xfrm>
+          <a:prstGeom prst="rect">
+            <a:avLst/>
+          </a:prstGeom>
+          <a:noFill/>
+          <a:ln/>
+        </p:spPr>
+        <p:txBody>
+          <a:bodyPr wrap="square" lIns="0" tIns="0" rIns="0" bIns="0" rtlCol="0" anchor="ctr"/>
+          <a:lstStyle/>
+          <a:p>
+            <a:pPr algn="ctr" indent="0" marL="0">
+              <a:buNone/>
+            </a:pPr>
+            <a:r>
+              <a:rPr lang="en-US" sz="1700" b="1" dirty="0">
+                <a:solidFill>
+                  <a:schemeClr val="tx1"/>
+                </a:solidFill>
+              </a:rPr>
+              <a:t>Frog: hibernation &amp; aestivation</a:t>
+            </a:r>
+            <a:endParaRPr lang="en-US" sz="1700" dirty="0"/>
+          </a:p>
+        </p:txBody>
+      </p:sp>
+      <p:sp>
+        <p:nvSpPr>
+          <p:cNvPr id="31" name="topic chip 11"/>
+          <p:cNvSpPr/>
+          <p:nvPr/>
+        </p:nvSpPr>
+        <p:spPr>
+          <a:xfrm>
+            <a:off x="8426196" y="3771900"/>
+            <a:ext cx="3040380" cy="493776"/>
+          </a:xfrm>
+          <a:prstGeom prst="roundRect">
+            <a:avLst>
+              <a:gd name="adj" fmla="val 57407"/>
+            </a:avLst>
+          </a:prstGeom>
+          <a:solidFill>
+            <a:srgbClr val="F4F8F8"/>
+          </a:solidFill>
+          <a:ln w="12700">
+            <a:solidFill>
+              <a:srgbClr val="D9E2E1"/>
+            </a:solidFill>
+            <a:prstDash val="solid"/>
+          </a:ln>
+        </p:spPr>
+      </p:sp>
+      <p:sp>
+        <p:nvSpPr>
+          <p:cNvPr id="32" name="topic 11"/>
+          <p:cNvSpPr txBox="1"/>
+          <p:nvPr/>
+        </p:nvSpPr>
+        <p:spPr>
+          <a:xfrm>
+            <a:off x="8426196" y="3771900"/>
+            <a:ext cx="3040380" cy="493776"/>
+          </a:xfrm>
+          <a:prstGeom prst="rect">
+            <a:avLst/>
+          </a:prstGeom>
+          <a:noFill/>
+          <a:ln/>
+        </p:spPr>
+        <p:txBody>
+          <a:bodyPr wrap="square" lIns="0" tIns="0" rIns="0" bIns="0" rtlCol="0" anchor="ctr"/>
+          <a:lstStyle/>
+          <a:p>
+            <a:pPr algn="ctr" indent="0" marL="0">
+              <a:buNone/>
+            </a:pPr>
+            <a:r>
+              <a:rPr lang="en-US" sz="1700" b="1" dirty="0">
+                <a:solidFill>
+                  <a:schemeClr val="tx1"/>
+                </a:solidFill>
+              </a:rPr>
+              <a:t>Frog digestive system</a:t>
+            </a:r>
+            <a:endParaRPr lang="en-US" sz="1700" dirty="0"/>
+          </a:p>
+        </p:txBody>
+      </p:sp>
+      <p:sp>
+        <p:nvSpPr>
+          <p:cNvPr id="33" name="tip box"/>
           <p:cNvSpPr/>
           <p:nvPr/>
         </p:nvSpPr>
@@ -13717,7 +13711,7 @@
       </p:sp>
       <p:pic>
         <p:nvPicPr>
-          <p:cNvPr id="30" name="tip icon" descr="preencoded.png">    </p:cNvPr>
+          <p:cNvPr id="34" name="tip icon" descr="preencoded.png">    </p:cNvPr>
           <p:cNvPicPr>
             <a:picLocks noChangeAspect="1"/>
           </p:cNvPicPr>
@@ -13741,7 +13735,7 @@
       </p:pic>
       <p:sp>
         <p:nvSpPr>
-          <p:cNvPr id="31" name="tip text"/>
+          <p:cNvPr id="35" name="tip text"/>
           <p:cNvSpPr txBox="1"/>
           <p:nvPr/>
         </p:nvSpPr>
@@ -14752,7 +14746,7 @@
                   <a:srgbClr val="FFFFFF"/>
                 </a:solidFill>
               </a:rPr>
-              <a:t>Placentation: draw all five types with an example each — marginal (pea), axile (tomato, lemon), parietal (mustard), free central (Dianthus), basal (sunflower).</a:t>
+              <a:t>Placentation: learn all five types with an example each — marginal (pea), axile (tomato, lemon), parietal (mustard), free central (Dianthus), basal (sunflower).</a:t>
             </a:r>
             <a:endParaRPr lang="en-US" sz="1500" dirty="0"/>
           </a:p>
@@ -15001,7 +14995,7 @@
                 <a:ea typeface="Cambria" pitchFamily="34" charset="-122"/>
                 <a:cs typeface="Cambria" pitchFamily="34" charset="-120"/>
               </a:rPr>
-              <a:t>25</a:t>
+              <a:t>21</a:t>
             </a:r>
             <a:endParaRPr lang="en-US" sz="8000" dirty="0"/>
           </a:p>

</xml_diff>